<commit_message>
Add the live deployment URL to the README and the deck
The app is deployed from master at cryptomarketanalysis.streamlit.app and
serves the same cached snapshot the repository ships with, so it opens
immediately with no credentials.

Co-Authored-By: Claude Opus 5 <noreply@anthropic.com>
</commit_message>
<xml_diff>
--- a/docs/Crypto_Market_Analysis_Final_Evaluation.pptx
+++ b/docs/Crypto_Market_Analysis_Final_Evaluation.pptx
@@ -2592,7 +2592,46 @@
         </p:nvSpPr>
         <p:spPr>
           <a:xfrm>
-            <a:off x="640080" y="5212080"/>
+            <a:off x="640080" y="4892040"/>
+            <a:ext cx="8229600" cy="365760"/>
+          </a:xfrm>
+          <a:prstGeom prst="rect">
+            <a:avLst/>
+          </a:prstGeom>
+          <a:noFill/>
+          <a:ln/>
+        </p:spPr>
+        <p:txBody>
+          <a:bodyPr wrap="square" lIns="0" tIns="0" rIns="0" bIns="0" rtlCol="0" anchor="ctr"/>
+          <a:lstStyle/>
+          <a:p>
+            <a:pPr indent="0" marL="0">
+              <a:buNone/>
+            </a:pPr>
+            <a:r>
+              <a:rPr lang="en-US" sz="1600" b="1" dirty="0">
+                <a:solidFill>
+                  <a:srgbClr val="00BCD4"/>
+                </a:solidFill>
+                <a:latin typeface="Calibri" pitchFamily="34" charset="0"/>
+                <a:ea typeface="Calibri" pitchFamily="34" charset="-122"/>
+                <a:cs typeface="Calibri" pitchFamily="34" charset="-120"/>
+              </a:rPr>
+              <a:t>cryptomarketanalysis.streamlit.app</a:t>
+            </a:r>
+            <a:endParaRPr lang="en-US" sz="1600" dirty="0"/>
+          </a:p>
+        </p:txBody>
+      </p:sp>
+      <p:sp>
+        <p:nvSpPr>
+          <p:cNvPr id="6" name="Text 4"/>
+          <p:cNvSpPr txBox="1"/>
+          <p:nvPr/>
+        </p:nvSpPr>
+        <p:spPr>
+          <a:xfrm>
+            <a:off x="640080" y="5394960"/>
             <a:ext cx="8229600" cy="731520"/>
           </a:xfrm>
           <a:prstGeom prst="rect">
@@ -5032,7 +5071,7 @@
                 <a:ea typeface="Cambria" pitchFamily="34" charset="-122"/>
                 <a:cs typeface="Cambria" pitchFamily="34" charset="-120"/>
               </a:rPr>
-              <a:t>Dated, not stale</a:t>
+              <a:t>Deployed and public</a:t>
             </a:r>
             <a:endParaRPr lang="en-US" sz="1700" dirty="0"/>
           </a:p>
@@ -5074,7 +5113,7 @@
                 <a:ea typeface="Calibri" pitchFamily="34" charset="-122"/>
                 <a:cs typeface="Calibri" pitchFamily="34" charset="-120"/>
               </a:rPr>
-              <a:t>The Datasets tab states the exact range each feed covers, so no figure is passed off as more current than it is.</a:t>
+              <a:t>Live at cryptomarketanalysis.streamlit.app, serving the same cached snapshot the repository ships with.</a:t>
             </a:r>
             <a:endParaRPr lang="en-US" sz="1200" dirty="0"/>
           </a:p>

</xml_diff>